<commit_message>
Regenerate and verify workshop decks, notebooks and project data
</commit_message>
<xml_diff>
--- a/slides/lecture1_honest_probabilities.pptx
+++ b/slides/lecture1_honest_probabilities.pptx
@@ -6762,7 +6762,7 @@
                 <a:ea typeface="Calibri" pitchFamily="34" charset="-122"/>
                 <a:cs typeface="Calibri" pitchFamily="34" charset="-120"/>
               </a:rPr>
-              <a:t>Site B has a sicker intake. Site C runs older analysers. Nothing about the model changes.</a:t>
+              <a:t>Site B has higher risk for similar recorded inputs. Site C has noisier measurements. The fitted model is unchanged.</a:t>
             </a:r>
             <a:endParaRPr lang="en-US" sz="1800" dirty="0"/>
           </a:p>
@@ -6872,7 +6872,7 @@
                 <a:ea typeface="Cambria" pitchFamily="34" charset="-122"/>
                 <a:cs typeface="Cambria" pitchFamily="34" charset="-120"/>
               </a:rPr>
-              <a:t>Ranking transfers. The numbers do not.</a:t>
+              <a:t>Here ranking holds, but risk estimates do not.</a:t>
             </a:r>
             <a:endParaRPr lang="en-US" sz="3000" dirty="0"/>
           </a:p>
@@ -7067,7 +7067,7 @@
                 <a:ea typeface="Cambria" pitchFamily="34" charset="-122"/>
                 <a:cs typeface="Cambria" pitchFamily="34" charset="-120"/>
               </a:rPr>
-              <a:t>Covariate monitoring sees one of these two failures</a:t>
+              <a:t>Input monitoring sees only part of the problem</a:t>
             </a:r>
             <a:endParaRPr lang="en-US" sz="3000" dirty="0"/>
           </a:p>
@@ -7188,7 +7188,7 @@
                 <a:ea typeface="Calibri" pitchFamily="34" charset="-122"/>
                 <a:cs typeface="Calibri" pitchFamily="34" charset="-120"/>
               </a:rPr>
-              <a:t>Site C is a covariate shift</a:t>
+              <a:t>Site C has measurement drift</a:t>
             </a:r>
             <a:endParaRPr lang="en-US" sz="1550" dirty="0"/>
           </a:p>
@@ -7230,7 +7230,7 @@
                 <a:ea typeface="Calibri" pitchFamily="34" charset="-122"/>
                 <a:cs typeface="Calibri" pitchFamily="34" charset="-120"/>
               </a:rPr>
-              <a:t>Large standardised mean differences on lactate, creatinine and WBC. A drift alarm fires on day one, with no outcome labels needed.</a:t>
+              <a:t>Some measured labs change because instruments are noisier. Input checks can detect a change, but this is not necessarily pure covariate shift.</a:t>
             </a:r>
             <a:endParaRPr lang="en-US" sz="1350" dirty="0"/>
           </a:p>
@@ -9295,7 +9295,7 @@
                 <a:ea typeface="Calibri" pitchFamily="34" charset="-122"/>
                 <a:cs typeface="Calibri" pitchFamily="34" charset="-120"/>
               </a:rPr>
-              <a:t>Repairing calibration at a new site and what it costs in labelled patients. Using ensemble disagreement to decide when a model should refuse to answer. Choosing an operating threshold from clinical costs rather than from 0.5. Borrowing strength across hospitals with hierarchical models. Then the project: six teams, one task, six different reasons not to deploy.</a:t>
+              <a:t>Repairing calibration at a new site and what it costs in labelled patients. Using ensemble disagreement to decide when a model should refuse to answer. Choosing an operating threshold from clinical costs rather than from 0.5. Borrowing strength across hospitals with hierarchical models. Then an open project: should we trust a model at a new hospital with only a small outcome audit?</a:t>
             </a:r>
             <a:endParaRPr lang="en-US" sz="1800" dirty="0"/>
           </a:p>
@@ -9405,7 +9405,7 @@
                 <a:ea typeface="Cambria" pitchFamily="34" charset="-122"/>
                 <a:cs typeface="Cambria" pitchFamily="34" charset="-120"/>
               </a:rPr>
-              <a:t>Six ideas, one hour and a half</a:t>
+              <a:t>Six ideas, one clinical question</a:t>
             </a:r>
             <a:endParaRPr lang="en-US" sz="3000" dirty="0"/>
           </a:p>
@@ -9685,7 +9685,7 @@
                 <a:ea typeface="Calibri" pitchFamily="34" charset="-122"/>
                 <a:cs typeface="Calibri" pitchFamily="34" charset="-120"/>
               </a:rPr>
-              <a:t>Only one of them survives a change of hospital</a:t>
+              <a:t>Neither is guaranteed to transfer across hospitals</a:t>
             </a:r>
             <a:endParaRPr lang="en-US" sz="1450" dirty="0"/>
           </a:p>

</xml_diff>